<commit_message>
docs: add transactional email demo
</commit_message>
<xml_diff>
--- a/docs/factor_ai_platform_demo_user_guide_2026-07-26_en.pptx
+++ b/docs/factor_ai_platform_demo_user_guide_2026-07-26_en.pptx
@@ -28,6 +28,7 @@
     <p:sldId id="276" r:id="rId27"/>
     <p:sldId id="277" r:id="rId28"/>
     <p:sldId id="278" r:id="rId29"/>
+    <p:sldId id="279" r:id="rId30"/>
   </p:sldIdLst>
   <p:sldSz cx="12191695" cy="6858000" type="screen4x3"/>
   <p:notesSz cx="6858000" cy="9144000"/>
@@ -6647,6 +6648,253 @@
                 </a:solidFill>
               </a:rPr>
               <a:t>• Prompt-version history and action logs support governance of the agentic platform.</a:t>
+            </a:r>
+          </a:p>
+        </p:txBody>
+      </p:sp>
+      <p:sp>
+        <p:nvSpPr>
+          <p:cNvPr id="7" name="TextBox 6"/>
+          <p:cNvSpPr txBox="1"/>
+          <p:nvPr/>
+        </p:nvSpPr>
+        <p:spPr>
+          <a:xfrm>
+            <a:off x="7543800" y="5989320"/>
+            <a:ext cx="4023360" cy="274320"/>
+          </a:xfrm>
+          <a:prstGeom prst="rect">
+            <a:avLst/>
+          </a:prstGeom>
+          <a:noFill/>
+        </p:spPr>
+        <p:txBody>
+          <a:bodyPr wrap="square" anchor="t">
+            <a:spAutoFit/>
+          </a:bodyPr>
+          <a:lstStyle/>
+          <a:p>
+            <a:r>
+              <a:rPr sz="900" b="1">
+                <a:solidFill>
+                  <a:srgbClr val="5C6860"/>
+                </a:solidFill>
+              </a:rPr>
+              <a:t>DEMO · SYNTHETIC DATA</a:t>
+            </a:r>
+          </a:p>
+        </p:txBody>
+      </p:sp>
+    </p:spTree>
+  </p:cSld>
+  <p:clrMapOvr>
+    <a:masterClrMapping/>
+  </p:clrMapOvr>
+</p:sld>
+</file>
+
+<file path=ppt/slides/slide24.xml><?xml version="1.0" encoding="utf-8"?>
+<p:sld xmlns:a="http://schemas.openxmlformats.org/drawingml/2006/main" xmlns:p="http://schemas.openxmlformats.org/presentationml/2006/main" xmlns:r="http://schemas.openxmlformats.org/officeDocument/2006/relationships">
+  <p:cSld>
+    <p:spTree>
+      <p:nvGrpSpPr>
+        <p:cNvPr id="1" name=""/>
+        <p:cNvGrpSpPr/>
+        <p:nvPr/>
+      </p:nvGrpSpPr>
+      <p:grpSpPr/>
+      <p:sp>
+        <p:nvSpPr>
+          <p:cNvPr id="2" name="Rectangle 1"/>
+          <p:cNvSpPr/>
+          <p:nvPr/>
+        </p:nvSpPr>
+        <p:spPr>
+          <a:xfrm>
+            <a:off x="0" y="0"/>
+            <a:ext cx="12191695" cy="6858000"/>
+          </a:xfrm>
+          <a:prstGeom prst="rect">
+            <a:avLst/>
+          </a:prstGeom>
+          <a:solidFill>
+            <a:srgbClr val="F7F6F1"/>
+          </a:solidFill>
+          <a:ln>
+            <a:noFill/>
+          </a:ln>
+        </p:spPr>
+        <p:style>
+          <a:lnRef idx="1">
+            <a:schemeClr val="accent1"/>
+          </a:lnRef>
+          <a:fillRef idx="3">
+            <a:schemeClr val="accent1"/>
+          </a:fillRef>
+          <a:effectRef idx="2">
+            <a:schemeClr val="accent1"/>
+          </a:effectRef>
+          <a:fontRef idx="minor">
+            <a:schemeClr val="lt1"/>
+          </a:fontRef>
+        </p:style>
+        <p:txBody>
+          <a:bodyPr rtlCol="0" anchor="ctr"/>
+          <a:lstStyle/>
+          <a:p>
+            <a:pPr algn="ctr"/>
+          </a:p>
+        </p:txBody>
+      </p:sp>
+      <p:sp>
+        <p:nvSpPr>
+          <p:cNvPr id="3" name="TextBox 2"/>
+          <p:cNvSpPr txBox="1"/>
+          <p:nvPr/>
+        </p:nvSpPr>
+        <p:spPr>
+          <a:xfrm>
+            <a:off x="502920" y="228600"/>
+            <a:ext cx="11155680" cy="274320"/>
+          </a:xfrm>
+          <a:prstGeom prst="rect">
+            <a:avLst/>
+          </a:prstGeom>
+          <a:noFill/>
+        </p:spPr>
+        <p:txBody>
+          <a:bodyPr wrap="square" anchor="t">
+            <a:spAutoFit/>
+          </a:bodyPr>
+          <a:lstStyle/>
+          <a:p>
+            <a:r>
+              <a:rPr sz="1000" b="1">
+                <a:solidFill>
+                  <a:srgbClr val="1F5D43"/>
+                </a:solidFill>
+              </a:rPr>
+              <a:t>3. ADMIN</a:t>
+            </a:r>
+          </a:p>
+        </p:txBody>
+      </p:sp>
+      <p:sp>
+        <p:nvSpPr>
+          <p:cNvPr id="4" name="TextBox 3"/>
+          <p:cNvSpPr txBox="1"/>
+          <p:nvPr/>
+        </p:nvSpPr>
+        <p:spPr>
+          <a:xfrm>
+            <a:off x="502920" y="566928"/>
+            <a:ext cx="11155680" cy="594360"/>
+          </a:xfrm>
+          <a:prstGeom prst="rect">
+            <a:avLst/>
+          </a:prstGeom>
+          <a:noFill/>
+        </p:spPr>
+        <p:txBody>
+          <a:bodyPr wrap="square" anchor="t">
+            <a:spAutoFit/>
+          </a:bodyPr>
+          <a:lstStyle/>
+          <a:p>
+            <a:r>
+              <a:rPr sz="2400" b="1">
+                <a:solidFill>
+                  <a:srgbClr val="1F5D43"/>
+                </a:solidFill>
+              </a:rPr>
+              <a:t>Prepare borrower transactional emails</a:t>
+            </a:r>
+          </a:p>
+        </p:txBody>
+      </p:sp>
+      <p:pic>
+        <p:nvPicPr>
+          <p:cNvPr id="5" name="Picture 4" descr="20-admin-email-templates.png"/>
+          <p:cNvPicPr>
+            <a:picLocks noChangeAspect="1"/>
+          </p:cNvPicPr>
+          <p:nvPr/>
+        </p:nvPicPr>
+        <p:blipFill>
+          <a:blip r:embed="rId2"/>
+          <a:stretch>
+            <a:fillRect/>
+          </a:stretch>
+        </p:blipFill>
+        <p:spPr>
+          <a:xfrm>
+            <a:off x="502920" y="1703070"/>
+            <a:ext cx="6766560" cy="4229100"/>
+          </a:xfrm>
+          <a:prstGeom prst="rect">
+            <a:avLst/>
+          </a:prstGeom>
+        </p:spPr>
+      </p:pic>
+      <p:sp>
+        <p:nvSpPr>
+          <p:cNvPr id="6" name="TextBox 5"/>
+          <p:cNvSpPr txBox="1"/>
+          <p:nvPr/>
+        </p:nvSpPr>
+        <p:spPr>
+          <a:xfrm>
+            <a:off x="7543800" y="1417320"/>
+            <a:ext cx="4069080" cy="4480560"/>
+          </a:xfrm>
+          <a:prstGeom prst="rect">
+            <a:avLst/>
+          </a:prstGeom>
+          <a:noFill/>
+        </p:spPr>
+        <p:txBody>
+          <a:bodyPr wrap="square" anchor="t">
+            <a:spAutoFit/>
+          </a:bodyPr>
+          <a:lstStyle/>
+          <a:p>
+            <a:r>
+              <a:rPr sz="1400" b="0">
+                <a:solidFill>
+                  <a:srgbClr val="14231B"/>
+                </a:solidFill>
+              </a:rPr>
+              <a:t>• Customer Service can render Factorio-branded bank-connection and accounting-connection reminders from checked-in Markdown templates.</a:t>
+            </a:r>
+          </a:p>
+          <a:p>
+            <a:pPr>
+              <a:spcBef>
+                <a:spcPts val="1300"/>
+              </a:spcBef>
+            </a:pPr>
+            <a:r>
+              <a:rPr sz="1400">
+                <a:solidFill>
+                  <a:srgbClr val="14231B"/>
+                </a:solidFill>
+              </a:rPr>
+              <a:t>• Each draft uses a personalized HTTPS resume link, support contact, and application-specific wording without sensitive bank or accounting credentials.</a:t>
+            </a:r>
+          </a:p>
+          <a:p>
+            <a:pPr>
+              <a:spcBef>
+                <a:spcPts val="1300"/>
+              </a:spcBef>
+            </a:pPr>
+            <a:r>
+              <a:rPr sz="1400">
+                <a:solidFill>
+                  <a:srgbClr val="14231B"/>
+                </a:solidFill>
+              </a:rPr>
+              <a:t>• Delivery is disabled in this demo until Postmark, a verified sender, approval/lifecycle triggers, audit records, and delivery webhooks are configured.</a:t>
             </a:r>
           </a:p>
         </p:txBody>

</xml_diff>